<commit_message>
fix(mcp deck): two lines agree with what the lab's test showed
A tool's name counts as much as its description when a model chooses:
tested through function calling on 6 Oct 2026, a tool named power was
called whatever its description said.

- "The listing is all it knows": matching is against the names and
  descriptions.
- "Common mistakes": a name and description that say nothing, then
  wondering why another tool is called.

Co-Authored-By: Claude Opus 5.5 <noreply@anthropic.com>
Claude-Session: https://claude.ai/code/session_01EoUxwm59J1bPmZ3iTg8Yri
</commit_message>
<xml_diff>
--- a/lectures-and-labs/week05/mcp-lecture.pptx
+++ b/lectures-and-labs/week05/mcp-lecture.pptx
@@ -24620,7 +24620,7 @@
               <a:t>matching</a:t>
             </a:r>
             <a:r>
-              <a:t>: the user's words against the descriptions</a:t>
+              <a:t>: the user's words against the names and descriptions</a:t>
             </a:r>
           </a:p>
           <a:p>
@@ -38962,7 +38962,7 @@
           <a:p>
             <a:pPr/>
             <a:r>
-              <a:t>A terse description, then wondering why the tool is never called</a:t>
+              <a:t>A name and description that say nothing, then wondering why another tool is called</a:t>
             </a:r>
           </a:p>
           <a:p>

</xml_diff>